<commit_message>
Update SCEPTRE notebook, reports, figures, and deliverables
</commit_message>
<xml_diff>
--- a/SCEPTRE_Review.pptx
+++ b/SCEPTRE_Review.pptx
@@ -4279,7 +4279,7 @@
                           </a:solidFill>
                           <a:latin typeface="Calibri"/>
                         </a:rPr>
-                        <a:t>0.664 +/- 0.002</a:t>
+                        <a:t>0.982 +/- 0.004</a:t>
                       </a:r>
                     </a:p>
                   </a:txBody>
@@ -4301,7 +4301,7 @@
                           </a:solidFill>
                           <a:latin typeface="Calibri"/>
                         </a:rPr>
-                        <a:t>929,671</a:t>
+                        <a:t>929,670</a:t>
                       </a:r>
                     </a:p>
                   </a:txBody>
@@ -4347,7 +4347,7 @@
                           </a:solidFill>
                           <a:latin typeface="Calibri"/>
                         </a:rPr>
-                        <a:t>0.665 +/- 0.004</a:t>
+                        <a:t>0.982 +/- 0.008</a:t>
                       </a:r>
                     </a:p>
                   </a:txBody>
@@ -4369,7 +4369,7 @@
                           </a:solidFill>
                           <a:latin typeface="Calibri"/>
                         </a:rPr>
-                        <a:t>1,447,111</a:t>
+                        <a:t>1,447,110</a:t>
                       </a:r>
                     </a:p>
                   </a:txBody>
@@ -4415,7 +4415,7 @@
                           </a:solidFill>
                           <a:latin typeface="Calibri"/>
                         </a:rPr>
-                        <a:t>0.666 +/- 0.004</a:t>
+                        <a:t>0.974 +/- 0.003</a:t>
                       </a:r>
                     </a:p>
                   </a:txBody>
@@ -4437,7 +4437,7 @@
                           </a:solidFill>
                           <a:latin typeface="Calibri"/>
                         </a:rPr>
-                        <a:t>1,380,871</a:t>
+                        <a:t>1,380,870</a:t>
                       </a:r>
                     </a:p>
                   </a:txBody>
@@ -4483,7 +4483,7 @@
                           </a:solidFill>
                           <a:latin typeface="Calibri"/>
                         </a:rPr>
-                        <a:t>0.666 +/- 0.001</a:t>
+                        <a:t>0.986 +/- 0.003</a:t>
                       </a:r>
                     </a:p>
                   </a:txBody>
@@ -4505,7 +4505,7 @@
                           </a:solidFill>
                           <a:latin typeface="Calibri"/>
                         </a:rPr>
-                        <a:t>935,047</a:t>
+                        <a:t>935,046</a:t>
                       </a:r>
                     </a:p>
                   </a:txBody>

</xml_diff>